<commit_message>
Add teaching-only disclaimer to README; update Session 2 and 3 slides and notebooks
</commit_message>
<xml_diff>
--- a/slides/AI Fundamentals for Healthcare - Session 2 - Classical Machine Learning.pptx
+++ b/slides/AI Fundamentals for Healthcare - Session 2 - Classical Machine Learning.pptx
@@ -5,42 +5,41 @@
     <p:sldMasterId id="2147483840" r:id="rId1"/>
   </p:sldMasterIdLst>
   <p:notesMasterIdLst>
-    <p:notesMasterId r:id="rId98"/>
+    <p:notesMasterId r:id="rId34"/>
   </p:notesMasterIdLst>
   <p:sldIdLst>
-    <p:sldId id="922" r:id="rId47"/>
-    <p:sldId id="924" r:id="rId103"/>
-    <p:sldId id="331" r:id="rId35"/>
-    <p:sldId id="332" r:id="rId36"/>
-    <p:sldId id="344" r:id="rId37"/>
-    <p:sldId id="333" r:id="rId38"/>
-    <p:sldId id="330" r:id="rId39"/>
-    <p:sldId id="329" r:id="rId40"/>
-    <p:sldId id="326" r:id="rId41"/>
-    <p:sldId id="310" r:id="rId68"/>
-    <p:sldId id="328" r:id="rId42"/>
-    <p:sldId id="327" r:id="rId43"/>
-    <p:sldId id="325" r:id="rId44"/>
-    <p:sldId id="320" r:id="rId52"/>
-    <p:sldId id="316" r:id="rId53"/>
-    <p:sldId id="925" r:id="rId104"/>
-    <p:sldId id="926" r:id="rId105"/>
-    <p:sldId id="322" r:id="rId50"/>
-    <p:sldId id="321" r:id="rId51"/>
-    <p:sldId id="349" r:id="rId63"/>
-    <p:sldId id="355" r:id="rId64"/>
-    <p:sldId id="356" r:id="rId65"/>
-    <p:sldId id="352" r:id="rId60"/>
-    <p:sldId id="353" r:id="rId61"/>
-    <p:sldId id="354" r:id="rId62"/>
-    <p:sldId id="314" r:id="rId58"/>
-    <p:sldId id="313" r:id="rId59"/>
-    <p:sldId id="927" r:id="rId106"/>
-    <p:sldId id="928" r:id="rId107"/>
-    <p:sldId id="929" r:id="rId108"/>
-    <p:sldId id="930" r:id="rId109"/>
-    <p:sldId id="931" r:id="rId110"/>
-    <p:sldId id="921" r:id="rId96"/>
+    <p:sldId id="922" r:id="rId2"/>
+    <p:sldId id="924" r:id="rId3"/>
+    <p:sldId id="331" r:id="rId4"/>
+    <p:sldId id="332" r:id="rId5"/>
+    <p:sldId id="344" r:id="rId6"/>
+    <p:sldId id="333" r:id="rId7"/>
+    <p:sldId id="330" r:id="rId8"/>
+    <p:sldId id="329" r:id="rId9"/>
+    <p:sldId id="326" r:id="rId10"/>
+    <p:sldId id="310" r:id="rId11"/>
+    <p:sldId id="328" r:id="rId12"/>
+    <p:sldId id="327" r:id="rId13"/>
+    <p:sldId id="325" r:id="rId14"/>
+    <p:sldId id="320" r:id="rId15"/>
+    <p:sldId id="316" r:id="rId16"/>
+    <p:sldId id="925" r:id="rId17"/>
+    <p:sldId id="926" r:id="rId18"/>
+    <p:sldId id="322" r:id="rId19"/>
+    <p:sldId id="321" r:id="rId20"/>
+    <p:sldId id="349" r:id="rId21"/>
+    <p:sldId id="355" r:id="rId22"/>
+    <p:sldId id="356" r:id="rId23"/>
+    <p:sldId id="352" r:id="rId24"/>
+    <p:sldId id="353" r:id="rId25"/>
+    <p:sldId id="354" r:id="rId26"/>
+    <p:sldId id="314" r:id="rId27"/>
+    <p:sldId id="313" r:id="rId28"/>
+    <p:sldId id="927" r:id="rId29"/>
+    <p:sldId id="928" r:id="rId30"/>
+    <p:sldId id="929" r:id="rId31"/>
+    <p:sldId id="931" r:id="rId32"/>
+    <p:sldId id="921" r:id="rId33"/>
   </p:sldIdLst>
   <p:sldSz cx="12192000" cy="6858000"/>
   <p:notesSz cx="6858000" cy="9144000"/>
@@ -158,6 +157,72 @@
 </p:presentation>
 </file>
 
+<file path=ppt/changesInfos/changesInfo1.xml><?xml version="1.0" encoding="utf-8"?>
+<pc:chgInfo xmlns:a="http://schemas.openxmlformats.org/drawingml/2006/main" xmlns:r="http://schemas.openxmlformats.org/officeDocument/2006/relationships" xmlns:ac="http://schemas.microsoft.com/office/drawing/2013/main/command" xmlns:pc="http://schemas.microsoft.com/office/powerpoint/2013/main/command">
+  <pc:docChgLst>
+    <pc:chgData name="Randy Giffen" userId="ba4c5031-b453-4aba-8832-4fb595fd4791" providerId="ADAL" clId="{2D00DA38-F308-5605-9C23-544637B15DA9}"/>
+    <pc:docChg chg="undo custSel addSld delSld modSld">
+      <pc:chgData name="Randy Giffen" userId="ba4c5031-b453-4aba-8832-4fb595fd4791" providerId="ADAL" clId="{2D00DA38-F308-5605-9C23-544637B15DA9}" dt="2026-10-03T15:11:33.227" v="5" actId="478"/>
+      <pc:docMkLst>
+        <pc:docMk/>
+      </pc:docMkLst>
+      <pc:sldChg chg="delSp mod">
+        <pc:chgData name="Randy Giffen" userId="ba4c5031-b453-4aba-8832-4fb595fd4791" providerId="ADAL" clId="{2D00DA38-F308-5605-9C23-544637B15DA9}" dt="2026-10-03T15:11:33.227" v="5" actId="478"/>
+        <pc:sldMkLst>
+          <pc:docMk/>
+          <pc:sldMk cId="2997766625" sldId="921"/>
+        </pc:sldMkLst>
+        <pc:picChg chg="del">
+          <ac:chgData name="Randy Giffen" userId="ba4c5031-b453-4aba-8832-4fb595fd4791" providerId="ADAL" clId="{2D00DA38-F308-5605-9C23-544637B15DA9}" dt="2026-10-03T15:11:33.227" v="5" actId="478"/>
+          <ac:picMkLst>
+            <pc:docMk/>
+            <pc:sldMk cId="2997766625" sldId="921"/>
+            <ac:picMk id="3" creationId="{5BE779F4-E0F1-5BC6-2417-93E6D6C2C83C}"/>
+          </ac:picMkLst>
+        </pc:picChg>
+      </pc:sldChg>
+      <pc:sldChg chg="delSp mod">
+        <pc:chgData name="Randy Giffen" userId="ba4c5031-b453-4aba-8832-4fb595fd4791" providerId="ADAL" clId="{2D00DA38-F308-5605-9C23-544637B15DA9}" dt="2026-10-03T15:09:08.782" v="1" actId="478"/>
+        <pc:sldMkLst>
+          <pc:docMk/>
+          <pc:sldMk cId="665887116" sldId="922"/>
+        </pc:sldMkLst>
+        <pc:spChg chg="del">
+          <ac:chgData name="Randy Giffen" userId="ba4c5031-b453-4aba-8832-4fb595fd4791" providerId="ADAL" clId="{2D00DA38-F308-5605-9C23-544637B15DA9}" dt="2026-10-03T15:09:01.952" v="0" actId="478"/>
+          <ac:spMkLst>
+            <pc:docMk/>
+            <pc:sldMk cId="665887116" sldId="922"/>
+            <ac:spMk id="5" creationId="{00000000-0000-0000-0000-000000000000}"/>
+          </ac:spMkLst>
+        </pc:spChg>
+        <pc:spChg chg="del">
+          <ac:chgData name="Randy Giffen" userId="ba4c5031-b453-4aba-8832-4fb595fd4791" providerId="ADAL" clId="{2D00DA38-F308-5605-9C23-544637B15DA9}" dt="2026-10-03T15:09:08.782" v="1" actId="478"/>
+          <ac:spMkLst>
+            <pc:docMk/>
+            <pc:sldMk cId="665887116" sldId="922"/>
+            <ac:spMk id="6" creationId="{00000000-0000-0000-0000-000000000000}"/>
+          </ac:spMkLst>
+        </pc:spChg>
+      </pc:sldChg>
+      <pc:sldChg chg="del">
+        <pc:chgData name="Randy Giffen" userId="ba4c5031-b453-4aba-8832-4fb595fd4791" providerId="ADAL" clId="{2D00DA38-F308-5605-9C23-544637B15DA9}" dt="2026-10-03T15:11:21.327" v="4" actId="2696"/>
+        <pc:sldMkLst>
+          <pc:docMk/>
+          <pc:sldMk cId="0" sldId="930"/>
+        </pc:sldMkLst>
+      </pc:sldChg>
+      <pc:sldChg chg="new del">
+        <pc:chgData name="Randy Giffen" userId="ba4c5031-b453-4aba-8832-4fb595fd4791" providerId="ADAL" clId="{2D00DA38-F308-5605-9C23-544637B15DA9}" dt="2026-10-03T15:11:15.009" v="3" actId="680"/>
+        <pc:sldMkLst>
+          <pc:docMk/>
+          <pc:sldMk cId="3614595132" sldId="932"/>
+        </pc:sldMkLst>
+      </pc:sldChg>
+    </pc:docChg>
+  </pc:docChgLst>
+</pc:chgInfo>
+</file>
+
 <file path=ppt/notesMasters/notesMaster1.xml><?xml version="1.0" encoding="utf-8"?>
 <p:notesMaster xmlns:a="http://schemas.openxmlformats.org/drawingml/2006/main" xmlns:r="http://schemas.openxmlformats.org/officeDocument/2006/relationships" xmlns:p="http://schemas.openxmlformats.org/presentationml/2006/main">
   <p:cSld>
@@ -240,7 +305,7 @@
           <a:p>
             <a:fld id="{A77F7983-855A-2240-A9BF-6235A2B9A807}" type="datetimeFigureOut">
               <a:rPr lang="en-US" smtClean="0"/>
-              <a:t>3/11/26</a:t>
+              <a:t>10/3/26</a:t>
             </a:fld>
             <a:endParaRPr lang="en-US"/>
           </a:p>
@@ -508,7 +573,7 @@
 </file>
 
 <file path=ppt/notesSlides/notesSlide1.xml><?xml version="1.0" encoding="utf-8"?>
-<p:notes xmlns:a="http://schemas.openxmlformats.org/drawingml/2006/main" xmlns:p="http://schemas.openxmlformats.org/presentationml/2006/main" xmlns:r="http://schemas.openxmlformats.org/officeDocument/2006/relationships">
+<p:notes xmlns:a="http://schemas.openxmlformats.org/drawingml/2006/main" xmlns:r="http://schemas.openxmlformats.org/officeDocument/2006/relationships" xmlns:p="http://schemas.openxmlformats.org/presentationml/2006/main">
   <p:cSld>
     <p:spTree>
       <p:nvGrpSpPr>
@@ -528,55 +593,43 @@
         <p:nvSpPr>
           <p:cNvPr id="2" name="Slide Image Placeholder 1"/>
           <p:cNvSpPr>
+            <a:spLocks noGrp="1" noRot="1" noChangeAspect="1"/>
+          </p:cNvSpPr>
+          <p:nvPr>
+            <p:ph type="sldImg" idx="2"/>
+          </p:nvPr>
+        </p:nvSpPr>
+        <p:spPr/>
+      </p:sp>
+      <p:sp>
+        <p:nvSpPr>
+          <p:cNvPr id="3" name="Notes Placeholder 2"/>
+          <p:cNvSpPr>
             <a:spLocks noGrp="1"/>
           </p:cNvSpPr>
           <p:nvPr>
-            <p:ph type="sldImg" idx="2"/>
+            <p:ph type="body" sz="quarter" idx="3"/>
           </p:nvPr>
         </p:nvSpPr>
         <p:spPr/>
-      </p:sp>
-      <p:sp>
-        <p:nvSpPr>
-          <p:cNvPr id="3" name="Notes Placeholder 2"/>
+        <p:txBody>
+          <a:bodyPr/>
+          <a:lstStyle/>
+          <a:p>
+            <a:r>
+              <a:t>Thirty seconds, no more. The purpose is to orient anyone who missed the previous session, not to re-teach it.</a:t>
+            </a:r>
+          </a:p>
+        </p:txBody>
+      </p:sp>
+      <p:sp>
+        <p:nvSpPr>
+          <p:cNvPr id="4" name="Slide Number Placeholder 3"/>
           <p:cNvSpPr>
             <a:spLocks noGrp="1"/>
           </p:cNvSpPr>
           <p:nvPr>
-            <p:ph type="body" idx="3" sz="quarter"/>
-          </p:nvPr>
-        </p:nvSpPr>
-        <p:spPr/>
-        <p:txBody>
-          <a:bodyPr/>
-          <a:lstStyle/>
-          <a:p>
-            <a:r>
-              <a:t>This is the slide that clinicians tend to find most obviously true and that data scientists most often get wrong. Use that.</a:t>
-            </a:r>
-          </a:p>
-          <a:p/>
-          <a:p>
-            <a:r>
-              <a:t>The reversal at the end matters: a model that learns 'lots of tests means sick' breaks the moment it meets a unit with a different ordering culture. That is a site-transfer failure, and it connects to the external validation slide coming up.</a:t>
-            </a:r>
-          </a:p>
-          <a:p/>
-          <a:p>
-            <a:r>
-              <a:t>About 4 minutes.</a:t>
-            </a:r>
-          </a:p>
-        </p:txBody>
-      </p:sp>
-      <p:sp>
-        <p:nvSpPr>
-          <p:cNvPr id="4" name="Slide Number Placeholder 3"/>
-          <p:cNvSpPr>
-            <a:spLocks noGrp="1"/>
-          </p:cNvSpPr>
-          <p:nvPr>
-            <p:ph type="sldNum" idx="5" sz="quarter"/>
+            <p:ph type="sldNum" sz="quarter" idx="5"/>
           </p:nvPr>
         </p:nvSpPr>
         <p:spPr/>
@@ -590,7 +643,7 @@
 </file>
 
 <file path=ppt/notesSlides/notesSlide10.xml><?xml version="1.0" encoding="utf-8"?>
-<p:notes xmlns:a="http://schemas.openxmlformats.org/drawingml/2006/main" xmlns:p="http://schemas.openxmlformats.org/presentationml/2006/main" xmlns:r="http://schemas.openxmlformats.org/officeDocument/2006/relationships">
+<p:notes xmlns:a="http://schemas.openxmlformats.org/drawingml/2006/main" xmlns:r="http://schemas.openxmlformats.org/officeDocument/2006/relationships" xmlns:p="http://schemas.openxmlformats.org/presentationml/2006/main">
   <p:cSld>
     <p:spTree>
       <p:nvGrpSpPr>
@@ -610,61 +663,51 @@
         <p:nvSpPr>
           <p:cNvPr id="2" name="Slide Image Placeholder 1"/>
           <p:cNvSpPr>
+            <a:spLocks noGrp="1" noRot="1" noChangeAspect="1"/>
+          </p:cNvSpPr>
+          <p:nvPr>
+            <p:ph type="sldImg" idx="2"/>
+          </p:nvPr>
+        </p:nvSpPr>
+        <p:spPr/>
+      </p:sp>
+      <p:sp>
+        <p:nvSpPr>
+          <p:cNvPr id="3" name="Notes Placeholder 2"/>
+          <p:cNvSpPr>
             <a:spLocks noGrp="1"/>
           </p:cNvSpPr>
           <p:nvPr>
-            <p:ph type="sldImg" idx="2"/>
+            <p:ph type="body" sz="quarter" idx="3"/>
           </p:nvPr>
         </p:nvSpPr>
         <p:spPr/>
-      </p:sp>
-      <p:sp>
-        <p:nvSpPr>
-          <p:cNvPr id="3" name="Notes Placeholder 2"/>
+        <p:txBody>
+          <a:bodyPr/>
+          <a:lstStyle/>
+          <a:p>
+            <a:r>
+              <a:t>Again, do not read it. Ask what they will check differently on Monday.</a:t>
+            </a:r>
+          </a:p>
+          <a:p>
+            <a:endParaRPr/>
+          </a:p>
+          <a:p>
+            <a:r>
+              <a:t>About 4 minutes.</a:t>
+            </a:r>
+          </a:p>
+        </p:txBody>
+      </p:sp>
+      <p:sp>
+        <p:nvSpPr>
+          <p:cNvPr id="4" name="Slide Number Placeholder 3"/>
           <p:cNvSpPr>
             <a:spLocks noGrp="1"/>
           </p:cNvSpPr>
           <p:nvPr>
-            <p:ph type="body" idx="3" sz="quarter"/>
-          </p:nvPr>
-        </p:nvSpPr>
-        <p:spPr/>
-        <p:txBody>
-          <a:bodyPr/>
-          <a:lstStyle/>
-          <a:p>
-            <a:r>
-              <a:t>Deliver this without triumphalism. The point is not that a vendor was wrong, it is that local validation is not optional.</a:t>
-            </a:r>
-          </a:p>
-          <a:p/>
-          <a:p>
-            <a:r>
-              <a:t>Avoid quoting precise figures from memory. The shape of the finding is what matters: materially worse than advertised, high alert burden, already in wide use.</a:t>
-            </a:r>
-          </a:p>
-          <a:p/>
-          <a:p>
-            <a:r>
-              <a:t>If someone asks whether their own tool has been externally validated, that is the best possible outcome for this slide.</a:t>
-            </a:r>
-          </a:p>
-          <a:p/>
-          <a:p>
-            <a:r>
-              <a:t>About 5 minutes.</a:t>
-            </a:r>
-          </a:p>
-        </p:txBody>
-      </p:sp>
-      <p:sp>
-        <p:nvSpPr>
-          <p:cNvPr id="4" name="Slide Number Placeholder 3"/>
-          <p:cNvSpPr>
-            <a:spLocks noGrp="1"/>
-          </p:cNvSpPr>
-          <p:nvPr>
-            <p:ph type="sldNum" idx="5" sz="quarter"/>
+            <p:ph type="sldNum" sz="quarter" idx="5"/>
           </p:nvPr>
         </p:nvSpPr>
         <p:spPr/>
@@ -677,8 +720,8 @@
 </p:notes>
 </file>
 
-<file path=ppt/notesSlides/notesSlide11.xml><?xml version="1.0" encoding="utf-8"?>
-<p:notes xmlns:a="http://schemas.openxmlformats.org/drawingml/2006/main" xmlns:p="http://schemas.openxmlformats.org/presentationml/2006/main" xmlns:r="http://schemas.openxmlformats.org/officeDocument/2006/relationships">
+<file path=ppt/notesSlides/notesSlide2.xml><?xml version="1.0" encoding="utf-8"?>
+<p:notes xmlns:a="http://schemas.openxmlformats.org/drawingml/2006/main" xmlns:r="http://schemas.openxmlformats.org/officeDocument/2006/relationships" xmlns:p="http://schemas.openxmlformats.org/presentationml/2006/main">
   <p:cSld>
     <p:spTree>
       <p:nvGrpSpPr>
@@ -698,22 +741,41 @@
         <p:nvSpPr>
           <p:cNvPr id="2" name="Slide Image Placeholder 1"/>
           <p:cNvSpPr>
+            <a:spLocks noGrp="1" noRot="1" noChangeAspect="1"/>
+          </p:cNvSpPr>
+          <p:nvPr>
+            <p:ph type="sldImg"/>
+          </p:nvPr>
+        </p:nvSpPr>
+        <p:spPr/>
+      </p:sp>
+      <p:sp>
+        <p:nvSpPr>
+          <p:cNvPr id="3" name="Notes Placeholder 2"/>
+          <p:cNvSpPr>
             <a:spLocks noGrp="1"/>
           </p:cNvSpPr>
           <p:nvPr>
-            <p:ph type="sldImg" idx="2"/>
+            <p:ph type="body" idx="1"/>
           </p:nvPr>
         </p:nvSpPr>
         <p:spPr/>
-      </p:sp>
-      <p:sp>
-        <p:nvSpPr>
-          <p:cNvPr id="3" name="Notes Placeholder 2"/>
+        <p:txBody>
+          <a:bodyPr/>
+          <a:lstStyle/>
+          <a:p>
+            <a:endParaRPr lang="en-US" dirty="0"/>
+          </a:p>
+        </p:txBody>
+      </p:sp>
+      <p:sp>
+        <p:nvSpPr>
+          <p:cNvPr id="4" name="Slide Number Placeholder 3"/>
           <p:cNvSpPr>
             <a:spLocks noGrp="1"/>
           </p:cNvSpPr>
           <p:nvPr>
-            <p:ph type="body" idx="3" sz="quarter"/>
+            <p:ph type="sldNum" sz="quarter" idx="5"/>
           </p:nvPr>
         </p:nvSpPr>
         <p:spPr/>
@@ -721,31 +783,20 @@
           <a:bodyPr/>
           <a:lstStyle/>
           <a:p>
-            <a:r>
-              <a:t>Again, do not read it. Ask what they will check differently on Monday.</a:t>
-            </a:r>
-          </a:p>
-          <a:p/>
-          <a:p>
-            <a:r>
-              <a:t>About 4 minutes.</a:t>
-            </a:r>
-          </a:p>
-        </p:txBody>
-      </p:sp>
-      <p:sp>
-        <p:nvSpPr>
-          <p:cNvPr id="4" name="Slide Number Placeholder 3"/>
-          <p:cNvSpPr>
-            <a:spLocks noGrp="1"/>
-          </p:cNvSpPr>
-          <p:nvPr>
-            <p:ph type="sldNum" idx="5" sz="quarter"/>
-          </p:nvPr>
-        </p:nvSpPr>
-        <p:spPr/>
+            <a:fld id="{0F578B63-BA6E-F541-BDDE-F9290717A250}" type="slidenum">
+              <a:rPr lang="en-US" smtClean="0"/>
+              <a:t>12</a:t>
+            </a:fld>
+            <a:endParaRPr lang="en-US"/>
+          </a:p>
+        </p:txBody>
       </p:sp>
     </p:spTree>
+    <p:extLst>
+      <p:ext uri="{BB962C8B-B14F-4D97-AF65-F5344CB8AC3E}">
+        <p14:creationId xmlns:p14="http://schemas.microsoft.com/office/powerpoint/2010/main" val="4001745051"/>
+      </p:ext>
+    </p:extLst>
   </p:cSld>
   <p:clrMapOvr>
     <a:masterClrMapping/>
@@ -753,8 +804,8 @@
 </p:notes>
 </file>
 
-<file path=ppt/notesSlides/notesSlide2.xml><?xml version="1.0" encoding="utf-8"?>
-<p:notes xmlns:a="http://schemas.openxmlformats.org/drawingml/2006/main" xmlns:p="http://schemas.openxmlformats.org/presentationml/2006/main" xmlns:r="http://schemas.openxmlformats.org/officeDocument/2006/relationships">
+<file path=ppt/notesSlides/notesSlide3.xml><?xml version="1.0" encoding="utf-8"?>
+<p:notes xmlns:a="http://schemas.openxmlformats.org/drawingml/2006/main" xmlns:r="http://schemas.openxmlformats.org/officeDocument/2006/relationships" xmlns:p="http://schemas.openxmlformats.org/presentationml/2006/main">
   <p:cSld>
     <p:spTree>
       <p:nvGrpSpPr>
@@ -774,125 +825,59 @@
         <p:nvSpPr>
           <p:cNvPr id="2" name="Slide Image Placeholder 1"/>
           <p:cNvSpPr>
+            <a:spLocks noGrp="1" noRot="1" noChangeAspect="1"/>
+          </p:cNvSpPr>
+          <p:nvPr>
+            <p:ph type="sldImg" idx="2"/>
+          </p:nvPr>
+        </p:nvSpPr>
+        <p:spPr/>
+      </p:sp>
+      <p:sp>
+        <p:nvSpPr>
+          <p:cNvPr id="3" name="Notes Placeholder 2"/>
+          <p:cNvSpPr>
             <a:spLocks noGrp="1"/>
           </p:cNvSpPr>
           <p:nvPr>
-            <p:ph type="sldImg" idx="2"/>
+            <p:ph type="body" sz="quarter" idx="3"/>
           </p:nvPr>
         </p:nvSpPr>
         <p:spPr/>
-      </p:sp>
-      <p:sp>
-        <p:nvSpPr>
-          <p:cNvPr id="3" name="Notes Placeholder 2"/>
+        <p:txBody>
+          <a:bodyPr/>
+          <a:lstStyle/>
+          <a:p>
+            <a:r>
+              <a:t>This is the single most common reason a clinical model looks brilliant in development and useless in practice. Worth slowing down for.</a:t>
+            </a:r>
+          </a:p>
+          <a:p>
+            <a:endParaRPr/>
+          </a:p>
+          <a:p>
+            <a:r>
+              <a:t>Good question for the room: what would leak in your own data? Someone usually names something specific to their service, and that lands better than the sepsis example.</a:t>
+            </a:r>
+          </a:p>
+          <a:p>
+            <a:endParaRPr/>
+          </a:p>
+          <a:p>
+            <a:r>
+              <a:t>About 5 minutes.</a:t>
+            </a:r>
+          </a:p>
+        </p:txBody>
+      </p:sp>
+      <p:sp>
+        <p:nvSpPr>
+          <p:cNvPr id="4" name="Slide Number Placeholder 3"/>
           <p:cNvSpPr>
             <a:spLocks noGrp="1"/>
           </p:cNvSpPr>
           <p:nvPr>
-            <p:ph type="body" idx="3" sz="quarter"/>
-          </p:nvPr>
-        </p:nvSpPr>
-        <p:spPr/>
-        <p:txBody>
-          <a:bodyPr/>
-          <a:lstStyle/>
-          <a:p>
-            <a:r>
-              <a:t>This is the single most common reason a clinical model looks brilliant in development and useless in practice. Worth slowing down for.</a:t>
-            </a:r>
-          </a:p>
-          <a:p/>
-          <a:p>
-            <a:r>
-              <a:t>Good question for the room: what would leak in your own data? Someone usually names something specific to their service, and that lands better than the sepsis example.</a:t>
-            </a:r>
-          </a:p>
-          <a:p/>
-          <a:p>
-            <a:r>
-              <a:t>About 5 minutes.</a:t>
-            </a:r>
-          </a:p>
-        </p:txBody>
-      </p:sp>
-      <p:sp>
-        <p:nvSpPr>
-          <p:cNvPr id="4" name="Slide Number Placeholder 3"/>
-          <p:cNvSpPr>
-            <a:spLocks noGrp="1"/>
-          </p:cNvSpPr>
-          <p:nvPr>
-            <p:ph type="sldNum" idx="5" sz="quarter"/>
-          </p:nvPr>
-        </p:nvSpPr>
-        <p:spPr/>
-      </p:sp>
-    </p:spTree>
-  </p:cSld>
-  <p:clrMapOvr>
-    <a:masterClrMapping/>
-  </p:clrMapOvr>
-</p:notes>
-</file>
-
-<file path=ppt/notesSlides/notesSlide3.xml><?xml version="1.0" encoding="utf-8"?>
-<p:notes xmlns:a="http://schemas.openxmlformats.org/drawingml/2006/main" xmlns:p="http://schemas.openxmlformats.org/presentationml/2006/main" xmlns:r="http://schemas.openxmlformats.org/officeDocument/2006/relationships">
-  <p:cSld>
-    <p:spTree>
-      <p:nvGrpSpPr>
-        <p:cNvPr id="1" name=""/>
-        <p:cNvGrpSpPr/>
-        <p:nvPr/>
-      </p:nvGrpSpPr>
-      <p:grpSpPr>
-        <a:xfrm>
-          <a:off x="0" y="0"/>
-          <a:ext cx="0" cy="0"/>
-          <a:chOff x="0" y="0"/>
-          <a:chExt cx="0" cy="0"/>
-        </a:xfrm>
-      </p:grpSpPr>
-      <p:sp>
-        <p:nvSpPr>
-          <p:cNvPr id="2" name="Slide Image Placeholder 1"/>
-          <p:cNvSpPr>
-            <a:spLocks noGrp="1"/>
-          </p:cNvSpPr>
-          <p:nvPr>
-            <p:ph type="sldImg" idx="2"/>
-          </p:nvPr>
-        </p:nvSpPr>
-        <p:spPr/>
-      </p:sp>
-      <p:sp>
-        <p:nvSpPr>
-          <p:cNvPr id="3" name="Notes Placeholder 2"/>
-          <p:cNvSpPr>
-            <a:spLocks noGrp="1"/>
-          </p:cNvSpPr>
-          <p:nvPr>
-            <p:ph type="body" idx="3" sz="quarter"/>
-          </p:nvPr>
-        </p:nvSpPr>
-        <p:spPr/>
-        <p:txBody>
-          <a:bodyPr/>
-          <a:lstStyle/>
-          <a:p>
-            <a:r>
-              <a:t>Thirty seconds, no more. The purpose is to orient anyone who missed the previous session, not to re-teach it.</a:t>
-            </a:r>
-          </a:p>
-        </p:txBody>
-      </p:sp>
-      <p:sp>
-        <p:nvSpPr>
-          <p:cNvPr id="4" name="Slide Number Placeholder 3"/>
-          <p:cNvSpPr>
-            <a:spLocks noGrp="1"/>
-          </p:cNvSpPr>
-          <p:nvPr>
-            <p:ph type="sldNum" idx="5" sz="quarter"/>
+            <p:ph type="sldNum" sz="quarter" idx="5"/>
           </p:nvPr>
         </p:nvSpPr>
         <p:spPr/>
@@ -929,7 +914,7 @@
             <a:spLocks noGrp="1" noRot="1" noChangeAspect="1"/>
           </p:cNvSpPr>
           <p:nvPr>
-            <p:ph type="sldImg"/>
+            <p:ph type="sldImg" idx="2"/>
           </p:nvPr>
         </p:nvSpPr>
         <p:spPr/>
@@ -941,7 +926,7 @@
             <a:spLocks noGrp="1"/>
           </p:cNvSpPr>
           <p:nvPr>
-            <p:ph type="body" idx="1"/>
+            <p:ph type="body" sz="quarter" idx="3"/>
           </p:nvPr>
         </p:nvSpPr>
         <p:spPr/>
@@ -949,7 +934,25 @@
           <a:bodyPr/>
           <a:lstStyle/>
           <a:p>
-            <a:endParaRPr lang="en-US" dirty="0"/>
+            <a:r>
+              <a:t>This is the slide that clinicians tend to find most obviously true and that data scientists most often get wrong. Use that.</a:t>
+            </a:r>
+          </a:p>
+          <a:p>
+            <a:endParaRPr/>
+          </a:p>
+          <a:p>
+            <a:r>
+              <a:t>The reversal at the end matters: a model that learns 'lots of tests means sick' breaks the moment it meets a unit with a different ordering culture. That is a site-transfer failure, and it connects to the external validation slide coming up.</a:t>
+            </a:r>
+          </a:p>
+          <a:p>
+            <a:endParaRPr/>
+          </a:p>
+          <a:p>
+            <a:r>
+              <a:t>About 4 minutes.</a:t>
+            </a:r>
           </a:p>
         </p:txBody>
       </p:sp>
@@ -964,24 +967,8 @@
           </p:nvPr>
         </p:nvSpPr>
         <p:spPr/>
-        <p:txBody>
-          <a:bodyPr/>
-          <a:lstStyle/>
-          <a:p>
-            <a:fld id="{0F578B63-BA6E-F541-BDDE-F9290717A250}" type="slidenum">
-              <a:rPr lang="en-US" smtClean="0"/>
-              <a:t>42</a:t>
-            </a:fld>
-            <a:endParaRPr lang="en-US"/>
-          </a:p>
-        </p:txBody>
       </p:sp>
     </p:spTree>
-    <p:extLst>
-      <p:ext uri="{BB962C8B-B14F-4D97-AF65-F5344CB8AC3E}">
-        <p14:creationId xmlns:p14="http://schemas.microsoft.com/office/powerpoint/2010/main" val="4001745051"/>
-      </p:ext>
-    </p:extLst>
   </p:cSld>
   <p:clrMapOvr>
     <a:masterClrMapping/>
@@ -1054,7 +1041,7 @@
           <a:p>
             <a:fld id="{0F578B63-BA6E-F541-BDDE-F9290717A250}" type="slidenum">
               <a:rPr lang="en-US" smtClean="0"/>
-              <a:t>63</a:t>
+              <a:t>21</a:t>
             </a:fld>
             <a:endParaRPr lang="en-US"/>
           </a:p>
@@ -1162,7 +1149,7 @@
           <a:p>
             <a:fld id="{0F578B63-BA6E-F541-BDDE-F9290717A250}" type="slidenum">
               <a:rPr lang="en-US" smtClean="0"/>
-              <a:t>64</a:t>
+              <a:t>22</a:t>
             </a:fld>
             <a:endParaRPr lang="en-US"/>
           </a:p>
@@ -1182,7 +1169,7 @@
 </file>
 
 <file path=ppt/notesSlides/notesSlide7.xml><?xml version="1.0" encoding="utf-8"?>
-<p:notes xmlns:a="http://schemas.openxmlformats.org/drawingml/2006/main" xmlns:p="http://schemas.openxmlformats.org/presentationml/2006/main" xmlns:r="http://schemas.openxmlformats.org/officeDocument/2006/relationships">
+<p:notes xmlns:a="http://schemas.openxmlformats.org/drawingml/2006/main" xmlns:r="http://schemas.openxmlformats.org/officeDocument/2006/relationships" xmlns:p="http://schemas.openxmlformats.org/presentationml/2006/main">
   <p:cSld>
     <p:spTree>
       <p:nvGrpSpPr>
@@ -1202,55 +1189,59 @@
         <p:nvSpPr>
           <p:cNvPr id="2" name="Slide Image Placeholder 1"/>
           <p:cNvSpPr>
+            <a:spLocks noGrp="1" noRot="1" noChangeAspect="1"/>
+          </p:cNvSpPr>
+          <p:nvPr>
+            <p:ph type="sldImg" idx="2"/>
+          </p:nvPr>
+        </p:nvSpPr>
+        <p:spPr/>
+      </p:sp>
+      <p:sp>
+        <p:nvSpPr>
+          <p:cNvPr id="3" name="Notes Placeholder 2"/>
+          <p:cNvSpPr>
             <a:spLocks noGrp="1"/>
           </p:cNvSpPr>
           <p:nvPr>
-            <p:ph type="sldImg" idx="2"/>
+            <p:ph type="body" sz="quarter" idx="3"/>
           </p:nvPr>
         </p:nvSpPr>
         <p:spPr/>
-      </p:sp>
-      <p:sp>
-        <p:nvSpPr>
-          <p:cNvPr id="3" name="Notes Placeholder 2"/>
+        <p:txBody>
+          <a:bodyPr/>
+          <a:lstStyle/>
+          <a:p>
+            <a:r>
+              <a:t>Most audiences have heard of AUC and have never heard of calibration. That gap is the reason this slide exists.</a:t>
+            </a:r>
+          </a:p>
+          <a:p>
+            <a:endParaRPr/>
+          </a:p>
+          <a:p>
+            <a:r>
+              <a:t>A concrete framing that works: a model that always says 5% when the true rate is 20% can still rank patients perfectly and win on AUC, while every number it reports is wrong. Nobody can set a threshold on it.</a:t>
+            </a:r>
+          </a:p>
+          <a:p>
+            <a:endParaRPr/>
+          </a:p>
+          <a:p>
+            <a:r>
+              <a:t>About 5 minutes.</a:t>
+            </a:r>
+          </a:p>
+        </p:txBody>
+      </p:sp>
+      <p:sp>
+        <p:nvSpPr>
+          <p:cNvPr id="4" name="Slide Number Placeholder 3"/>
           <p:cNvSpPr>
             <a:spLocks noGrp="1"/>
           </p:cNvSpPr>
           <p:nvPr>
-            <p:ph type="body" idx="3" sz="quarter"/>
-          </p:nvPr>
-        </p:nvSpPr>
-        <p:spPr/>
-        <p:txBody>
-          <a:bodyPr/>
-          <a:lstStyle/>
-          <a:p>
-            <a:r>
-              <a:t>Most audiences have heard of AUC and have never heard of calibration. That gap is the reason this slide exists.</a:t>
-            </a:r>
-          </a:p>
-          <a:p/>
-          <a:p>
-            <a:r>
-              <a:t>A concrete framing that works: a model that always says 5% when the true rate is 20% can still rank patients perfectly and win on AUC, while every number it reports is wrong. Nobody can set a threshold on it.</a:t>
-            </a:r>
-          </a:p>
-          <a:p/>
-          <a:p>
-            <a:r>
-              <a:t>About 5 minutes.</a:t>
-            </a:r>
-          </a:p>
-        </p:txBody>
-      </p:sp>
-      <p:sp>
-        <p:nvSpPr>
-          <p:cNvPr id="4" name="Slide Number Placeholder 3"/>
-          <p:cNvSpPr>
-            <a:spLocks noGrp="1"/>
-          </p:cNvSpPr>
-          <p:nvPr>
-            <p:ph type="sldNum" idx="5" sz="quarter"/>
+            <p:ph type="sldNum" sz="quarter" idx="5"/>
           </p:nvPr>
         </p:nvSpPr>
         <p:spPr/>
@@ -1264,7 +1255,7 @@
 </file>
 
 <file path=ppt/notesSlides/notesSlide8.xml><?xml version="1.0" encoding="utf-8"?>
-<p:notes xmlns:a="http://schemas.openxmlformats.org/drawingml/2006/main" xmlns:p="http://schemas.openxmlformats.org/presentationml/2006/main" xmlns:r="http://schemas.openxmlformats.org/officeDocument/2006/relationships">
+<p:notes xmlns:a="http://schemas.openxmlformats.org/drawingml/2006/main" xmlns:r="http://schemas.openxmlformats.org/officeDocument/2006/relationships" xmlns:p="http://schemas.openxmlformats.org/presentationml/2006/main">
   <p:cSld>
     <p:spTree>
       <p:nvGrpSpPr>
@@ -1284,55 +1275,59 @@
         <p:nvSpPr>
           <p:cNvPr id="2" name="Slide Image Placeholder 1"/>
           <p:cNvSpPr>
+            <a:spLocks noGrp="1" noRot="1" noChangeAspect="1"/>
+          </p:cNvSpPr>
+          <p:nvPr>
+            <p:ph type="sldImg" idx="2"/>
+          </p:nvPr>
+        </p:nvSpPr>
+        <p:spPr/>
+      </p:sp>
+      <p:sp>
+        <p:nvSpPr>
+          <p:cNvPr id="3" name="Notes Placeholder 2"/>
+          <p:cNvSpPr>
             <a:spLocks noGrp="1"/>
           </p:cNvSpPr>
           <p:nvPr>
-            <p:ph type="sldImg" idx="2"/>
+            <p:ph type="body" sz="quarter" idx="3"/>
           </p:nvPr>
         </p:nvSpPr>
         <p:spPr/>
-      </p:sp>
-      <p:sp>
-        <p:nvSpPr>
-          <p:cNvPr id="3" name="Notes Placeholder 2"/>
+        <p:txBody>
+          <a:bodyPr/>
+          <a:lstStyle/>
+          <a:p>
+            <a:r>
+              <a:t>The four tiers are the spine of this session. If the audience remembers one slide, make it this one.</a:t>
+            </a:r>
+          </a:p>
+          <a:p>
+            <a:endParaRPr/>
+          </a:p>
+          <a:p>
+            <a:r>
+              <a:t>The split-by-patient point is not a technicality. In our own notebook a disposition model scored 100% with a row-level split and 49% once we split by patient. Same data, same model, one honest number and one meaningless one.</a:t>
+            </a:r>
+          </a:p>
+          <a:p>
+            <a:endParaRPr/>
+          </a:p>
+          <a:p>
+            <a:r>
+              <a:t>About 6 minutes.</a:t>
+            </a:r>
+          </a:p>
+        </p:txBody>
+      </p:sp>
+      <p:sp>
+        <p:nvSpPr>
+          <p:cNvPr id="4" name="Slide Number Placeholder 3"/>
           <p:cNvSpPr>
             <a:spLocks noGrp="1"/>
           </p:cNvSpPr>
           <p:nvPr>
-            <p:ph type="body" idx="3" sz="quarter"/>
-          </p:nvPr>
-        </p:nvSpPr>
-        <p:spPr/>
-        <p:txBody>
-          <a:bodyPr/>
-          <a:lstStyle/>
-          <a:p>
-            <a:r>
-              <a:t>The four tiers are the spine of this session. If the audience remembers one slide, make it this one.</a:t>
-            </a:r>
-          </a:p>
-          <a:p/>
-          <a:p>
-            <a:r>
-              <a:t>The split-by-patient point is not a technicality. In our own notebook a disposition model scored 100% with a row-level split and 49% once we split by patient. Same data, same model, one honest number and one meaningless one.</a:t>
-            </a:r>
-          </a:p>
-          <a:p/>
-          <a:p>
-            <a:r>
-              <a:t>About 6 minutes.</a:t>
-            </a:r>
-          </a:p>
-        </p:txBody>
-      </p:sp>
-      <p:sp>
-        <p:nvSpPr>
-          <p:cNvPr id="4" name="Slide Number Placeholder 3"/>
-          <p:cNvSpPr>
-            <a:spLocks noGrp="1"/>
-          </p:cNvSpPr>
-          <p:nvPr>
-            <p:ph type="sldNum" idx="5" sz="quarter"/>
+            <p:ph type="sldNum" sz="quarter" idx="5"/>
           </p:nvPr>
         </p:nvSpPr>
         <p:spPr/>
@@ -1346,7 +1341,7 @@
 </file>
 
 <file path=ppt/notesSlides/notesSlide9.xml><?xml version="1.0" encoding="utf-8"?>
-<p:notes xmlns:a="http://schemas.openxmlformats.org/drawingml/2006/main" xmlns:p="http://schemas.openxmlformats.org/presentationml/2006/main" xmlns:r="http://schemas.openxmlformats.org/officeDocument/2006/relationships">
+<p:notes xmlns:a="http://schemas.openxmlformats.org/drawingml/2006/main" xmlns:r="http://schemas.openxmlformats.org/officeDocument/2006/relationships" xmlns:p="http://schemas.openxmlformats.org/presentationml/2006/main">
   <p:cSld>
     <p:spTree>
       <p:nvGrpSpPr>
@@ -1366,55 +1361,59 @@
         <p:nvSpPr>
           <p:cNvPr id="2" name="Slide Image Placeholder 1"/>
           <p:cNvSpPr>
+            <a:spLocks noGrp="1" noRot="1" noChangeAspect="1"/>
+          </p:cNvSpPr>
+          <p:nvPr>
+            <p:ph type="sldImg" idx="2"/>
+          </p:nvPr>
+        </p:nvSpPr>
+        <p:spPr/>
+      </p:sp>
+      <p:sp>
+        <p:nvSpPr>
+          <p:cNvPr id="3" name="Notes Placeholder 2"/>
+          <p:cNvSpPr>
             <a:spLocks noGrp="1"/>
           </p:cNvSpPr>
           <p:nvPr>
-            <p:ph type="sldImg" idx="2"/>
+            <p:ph type="body" sz="quarter" idx="3"/>
           </p:nvPr>
         </p:nvSpPr>
         <p:spPr/>
-      </p:sp>
-      <p:sp>
-        <p:nvSpPr>
-          <p:cNvPr id="3" name="Notes Placeholder 2"/>
+        <p:txBody>
+          <a:bodyPr/>
+          <a:lstStyle/>
+          <a:p>
+            <a:r>
+              <a:t>Take this slowly and get the mechanism right, because the detail is what makes it persuasive: the algorithm was never given race. It used cost as a proxy for need, and the proxy carried the inequity.</a:t>
+            </a:r>
+          </a:p>
+          <a:p>
+            <a:endParaRPr/>
+          </a:p>
+          <a:p>
+            <a:r>
+              <a:t>The transferable lesson is the last line. Cost, referral and coded diagnosis are all records of decisions somebody made, not measurements of a condition.</a:t>
+            </a:r>
+          </a:p>
+          <a:p>
+            <a:endParaRPr/>
+          </a:p>
+          <a:p>
+            <a:r>
+              <a:t>Expect this to generate discussion. Leave room for it. About 8 minutes.</a:t>
+            </a:r>
+          </a:p>
+        </p:txBody>
+      </p:sp>
+      <p:sp>
+        <p:nvSpPr>
+          <p:cNvPr id="4" name="Slide Number Placeholder 3"/>
           <p:cNvSpPr>
             <a:spLocks noGrp="1"/>
           </p:cNvSpPr>
           <p:nvPr>
-            <p:ph type="body" idx="3" sz="quarter"/>
-          </p:nvPr>
-        </p:nvSpPr>
-        <p:spPr/>
-        <p:txBody>
-          <a:bodyPr/>
-          <a:lstStyle/>
-          <a:p>
-            <a:r>
-              <a:t>Take this slowly and get the mechanism right, because the detail is what makes it persuasive: the algorithm was never given race. It used cost as a proxy for need, and the proxy carried the inequity.</a:t>
-            </a:r>
-          </a:p>
-          <a:p/>
-          <a:p>
-            <a:r>
-              <a:t>The transferable lesson is the last line. Cost, referral and coded diagnosis are all records of decisions somebody made, not measurements of a condition.</a:t>
-            </a:r>
-          </a:p>
-          <a:p/>
-          <a:p>
-            <a:r>
-              <a:t>Expect this to generate discussion. Leave room for it. About 8 minutes.</a:t>
-            </a:r>
-          </a:p>
-        </p:txBody>
-      </p:sp>
-      <p:sp>
-        <p:nvSpPr>
-          <p:cNvPr id="4" name="Slide Number Placeholder 3"/>
-          <p:cNvSpPr>
-            <a:spLocks noGrp="1"/>
-          </p:cNvSpPr>
-          <p:nvPr>
-            <p:ph type="sldNum" idx="5" sz="quarter"/>
+            <p:ph type="sldNum" sz="quarter" idx="5"/>
           </p:nvPr>
         </p:nvSpPr>
         <p:spPr/>
@@ -1666,7 +1665,7 @@
             <a:fld id="{5586B75A-687E-405C-8A0B-8D00578BA2C3}" type="datetimeFigureOut">
               <a:rPr lang="en-US" dirty="0"/>
               <a:pPr/>
-              <a:t>3/11/26</a:t>
+              <a:t>10/3/26</a:t>
             </a:fld>
             <a:endParaRPr lang="en-US" dirty="0"/>
           </a:p>
@@ -1833,7 +1832,7 @@
             <a:fld id="{5586B75A-687E-405C-8A0B-8D00578BA2C3}" type="datetimeFigureOut">
               <a:rPr lang="en-US" dirty="0"/>
               <a:pPr/>
-              <a:t>3/11/26</a:t>
+              <a:t>10/3/26</a:t>
             </a:fld>
             <a:endParaRPr lang="en-US" dirty="0"/>
           </a:p>
@@ -2010,7 +2009,7 @@
             <a:fld id="{5586B75A-687E-405C-8A0B-8D00578BA2C3}" type="datetimeFigureOut">
               <a:rPr lang="en-US" dirty="0"/>
               <a:pPr/>
-              <a:t>3/11/26</a:t>
+              <a:t>10/3/26</a:t>
             </a:fld>
             <a:endParaRPr lang="en-US" dirty="0"/>
           </a:p>
@@ -2177,7 +2176,7 @@
             <a:fld id="{5586B75A-687E-405C-8A0B-8D00578BA2C3}" type="datetimeFigureOut">
               <a:rPr lang="en-US" dirty="0"/>
               <a:pPr/>
-              <a:t>3/11/26</a:t>
+              <a:t>10/3/26</a:t>
             </a:fld>
             <a:endParaRPr lang="en-US" dirty="0"/>
           </a:p>
@@ -2432,7 +2431,7 @@
             <a:fld id="{5586B75A-687E-405C-8A0B-8D00578BA2C3}" type="datetimeFigureOut">
               <a:rPr lang="en-US" dirty="0"/>
               <a:pPr/>
-              <a:t>3/11/26</a:t>
+              <a:t>10/3/26</a:t>
             </a:fld>
             <a:endParaRPr lang="en-US" dirty="0"/>
           </a:p>
@@ -2717,7 +2716,7 @@
             <a:fld id="{5586B75A-687E-405C-8A0B-8D00578BA2C3}" type="datetimeFigureOut">
               <a:rPr lang="en-US" dirty="0"/>
               <a:pPr/>
-              <a:t>3/11/26</a:t>
+              <a:t>10/3/26</a:t>
             </a:fld>
             <a:endParaRPr lang="en-US" dirty="0"/>
           </a:p>
@@ -3156,7 +3155,7 @@
             <a:fld id="{5586B75A-687E-405C-8A0B-8D00578BA2C3}" type="datetimeFigureOut">
               <a:rPr lang="en-US" dirty="0"/>
               <a:pPr/>
-              <a:t>3/11/26</a:t>
+              <a:t>10/3/26</a:t>
             </a:fld>
             <a:endParaRPr lang="en-US" dirty="0"/>
           </a:p>
@@ -3271,7 +3270,7 @@
             <a:fld id="{5586B75A-687E-405C-8A0B-8D00578BA2C3}" type="datetimeFigureOut">
               <a:rPr lang="en-US" dirty="0"/>
               <a:pPr/>
-              <a:t>3/11/26</a:t>
+              <a:t>10/3/26</a:t>
             </a:fld>
             <a:endParaRPr lang="en-US" dirty="0"/>
           </a:p>
@@ -3363,7 +3362,7 @@
             <a:fld id="{5586B75A-687E-405C-8A0B-8D00578BA2C3}" type="datetimeFigureOut">
               <a:rPr lang="en-US" dirty="0"/>
               <a:pPr/>
-              <a:t>3/11/26</a:t>
+              <a:t>10/3/26</a:t>
             </a:fld>
             <a:endParaRPr lang="en-US" dirty="0"/>
           </a:p>
@@ -3648,7 +3647,7 @@
             <a:fld id="{5586B75A-687E-405C-8A0B-8D00578BA2C3}" type="datetimeFigureOut">
               <a:rPr lang="en-US" dirty="0"/>
               <a:pPr/>
-              <a:t>3/11/26</a:t>
+              <a:t>10/3/26</a:t>
             </a:fld>
             <a:endParaRPr lang="en-US" dirty="0"/>
           </a:p>
@@ -3918,7 +3917,7 @@
             <a:fld id="{5586B75A-687E-405C-8A0B-8D00578BA2C3}" type="datetimeFigureOut">
               <a:rPr lang="en-US" dirty="0"/>
               <a:pPr/>
-              <a:t>3/11/26</a:t>
+              <a:t>10/3/26</a:t>
             </a:fld>
             <a:endParaRPr lang="en-US" dirty="0"/>
           </a:p>
@@ -4225,7 +4224,7 @@
             <a:fld id="{5586B75A-687E-405C-8A0B-8D00578BA2C3}" type="datetimeFigureOut">
               <a:rPr lang="en-US" smtClean="0"/>
               <a:pPr/>
-              <a:t>3/11/26</a:t>
+              <a:t>10/3/26</a:t>
             </a:fld>
             <a:endParaRPr lang="en-US" dirty="0"/>
           </a:p>
@@ -4753,6 +4752,7 @@
           <a:lstStyle/>
           <a:p>
             <a:pPr algn="ctr"/>
+            <a:endParaRPr/>
           </a:p>
         </p:txBody>
       </p:sp>
@@ -4797,6 +4797,7 @@
           <a:lstStyle/>
           <a:p>
             <a:pPr algn="ctr"/>
+            <a:endParaRPr/>
           </a:p>
         </p:txBody>
       </p:sp>
@@ -4846,86 +4847,6 @@
                 <a:latin typeface="Calibri"/>
               </a:rPr>
               <a:t>Session 2 of 4 — Classical Machine Learning</a:t>
-            </a:r>
-          </a:p>
-        </p:txBody>
-      </p:sp>
-      <p:sp>
-        <p:nvSpPr>
-          <p:cNvPr id="5" name="TextBox 4"/>
-          <p:cNvSpPr txBox="1"/>
-          <p:nvPr/>
-        </p:nvSpPr>
-        <p:spPr>
-          <a:xfrm>
-            <a:off x="822960" y="6263640"/>
-            <a:ext cx="9265920" cy="457200"/>
-          </a:xfrm>
-          <a:prstGeom prst="rect">
-            <a:avLst/>
-          </a:prstGeom>
-          <a:noFill/>
-        </p:spPr>
-        <p:txBody>
-          <a:bodyPr wrap="square">
-            <a:spAutoFit/>
-          </a:bodyPr>
-          <a:lstStyle/>
-          <a:p>
-            <a:r>
-              <a:rPr sz="1200">
-                <a:solidFill>
-                  <a:srgbClr val="EDF1F2"/>
-                </a:solidFill>
-                <a:latin typeface="Calibri"/>
-              </a:rPr>
-              <a:t>January 16, 2026</a:t>
-            </a:r>
-          </a:p>
-          <a:p>
-            <a:r>
-              <a:rPr sz="1200">
-                <a:solidFill>
-                  <a:srgbClr val="EDF1F2"/>
-                </a:solidFill>
-                <a:latin typeface="Calibri"/>
-              </a:rPr>
-              <a:t>Emera Innovation Exchange</a:t>
-            </a:r>
-          </a:p>
-        </p:txBody>
-      </p:sp>
-      <p:sp>
-        <p:nvSpPr>
-          <p:cNvPr id="6" name="TextBox 5"/>
-          <p:cNvSpPr txBox="1"/>
-          <p:nvPr/>
-        </p:nvSpPr>
-        <p:spPr>
-          <a:xfrm>
-            <a:off x="9814560" y="6263640"/>
-            <a:ext cx="1828800" cy="365760"/>
-          </a:xfrm>
-          <a:prstGeom prst="rect">
-            <a:avLst/>
-          </a:prstGeom>
-          <a:noFill/>
-        </p:spPr>
-        <p:txBody>
-          <a:bodyPr wrap="none">
-            <a:spAutoFit/>
-          </a:bodyPr>
-          <a:lstStyle/>
-          <a:p>
-            <a:pPr algn="r"/>
-            <a:r>
-              <a:rPr sz="1200" b="1">
-                <a:solidFill>
-                  <a:srgbClr val="FFFFFF"/>
-                </a:solidFill>
-                <a:latin typeface="Calibri"/>
-              </a:rPr>
-              <a:t>cair.ca</a:t>
             </a:r>
           </a:p>
         </p:txBody>
@@ -5233,7 +5154,7 @@
           <p:nvPr/>
         </p:nvPicPr>
         <p:blipFill>
-          <a:blip r:embed="rId4"/>
+          <a:blip r:embed="rId3"/>
           <a:stretch>
             <a:fillRect/>
           </a:stretch>
@@ -5752,7 +5673,7 @@
 </file>
 
 <file path=ppt/slides/slide16.xml><?xml version="1.0" encoding="utf-8"?>
-<p:sld xmlns:a="http://schemas.openxmlformats.org/drawingml/2006/main" xmlns:p="http://schemas.openxmlformats.org/presentationml/2006/main" xmlns:r="http://schemas.openxmlformats.org/officeDocument/2006/relationships">
+<p:sld xmlns:a="http://schemas.openxmlformats.org/drawingml/2006/main" xmlns:r="http://schemas.openxmlformats.org/officeDocument/2006/relationships" xmlns:p="http://schemas.openxmlformats.org/presentationml/2006/main">
   <p:cSld>
     <p:spTree>
       <p:nvGrpSpPr>
@@ -5760,7 +5681,14 @@
         <p:cNvGrpSpPr/>
         <p:nvPr/>
       </p:nvGrpSpPr>
-      <p:grpSpPr/>
+      <p:grpSpPr>
+        <a:xfrm>
+          <a:off x="0" y="0"/>
+          <a:ext cx="0" cy="0"/>
+          <a:chOff x="0" y="0"/>
+          <a:chExt cx="0" cy="0"/>
+        </a:xfrm>
+      </p:grpSpPr>
       <p:sp>
         <p:nvSpPr>
           <p:cNvPr id="2" name="Title 1"/>
@@ -5797,13 +5725,11 @@
           <a:bodyPr/>
           <a:lstStyle/>
           <a:p>
-            <a:pPr/>
             <a:r>
               <a:t>A model that looks excellent in testing is often reading the answer rather than predicting it.</a:t>
             </a:r>
           </a:p>
           <a:p>
-            <a:pPr/>
             <a:r>
               <a:t>Example: predicting sepsis from a feature set that includes the antibiotic order.</a:t>
             </a:r>
@@ -5815,7 +5741,6 @@
             </a:r>
           </a:p>
           <a:p>
-            <a:pPr/>
             <a:r>
               <a:t>Common leaks in hospital data:</a:t>
             </a:r>
@@ -5839,13 +5764,11 @@
             </a:r>
           </a:p>
           <a:p>
-            <a:pPr/>
             <a:r>
               <a:t>The test to apply: could this value have been recorded before the moment the prediction is made?</a:t>
             </a:r>
           </a:p>
           <a:p>
-            <a:pPr/>
             <a:r>
               <a:t>Leakage does not appear as an error. It appears as suspiciously good performance.</a:t>
             </a:r>
@@ -5861,7 +5784,7 @@
 </file>
 
 <file path=ppt/slides/slide17.xml><?xml version="1.0" encoding="utf-8"?>
-<p:sld xmlns:a="http://schemas.openxmlformats.org/drawingml/2006/main" xmlns:p="http://schemas.openxmlformats.org/presentationml/2006/main" xmlns:r="http://schemas.openxmlformats.org/officeDocument/2006/relationships">
+<p:sld xmlns:a="http://schemas.openxmlformats.org/drawingml/2006/main" xmlns:r="http://schemas.openxmlformats.org/officeDocument/2006/relationships" xmlns:p="http://schemas.openxmlformats.org/presentationml/2006/main">
   <p:cSld>
     <p:spTree>
       <p:nvGrpSpPr>
@@ -5869,7 +5792,14 @@
         <p:cNvGrpSpPr/>
         <p:nvPr/>
       </p:nvGrpSpPr>
-      <p:grpSpPr/>
+      <p:grpSpPr>
+        <a:xfrm>
+          <a:off x="0" y="0"/>
+          <a:ext cx="0" cy="0"/>
+          <a:chOff x="0" y="0"/>
+          <a:chExt cx="0" cy="0"/>
+        </a:xfrm>
+      </p:grpSpPr>
       <p:sp>
         <p:nvSpPr>
           <p:cNvPr id="2" name="Title 1"/>
@@ -5906,31 +5836,26 @@
           <a:bodyPr/>
           <a:lstStyle/>
           <a:p>
-            <a:pPr/>
             <a:r>
               <a:t>In most datasets a missing value is an accident. In clinical data it is usually a decision.</a:t>
             </a:r>
           </a:p>
           <a:p>
-            <a:pPr/>
             <a:r>
               <a:t>A test that was not ordered tells you the clinician was not concerned.</a:t>
             </a:r>
           </a:p>
           <a:p>
-            <a:pPr/>
             <a:r>
               <a:t>A patient with no overnight observations was probably well enough to be left asleep.</a:t>
             </a:r>
           </a:p>
           <a:p>
-            <a:pPr/>
             <a:r>
               <a:t>Filling the gap with the column mean erases that signal, and can reverse it.</a:t>
             </a:r>
           </a:p>
           <a:p>
-            <a:pPr/>
             <a:r>
               <a:t>Practical approach:</a:t>
             </a:r>
@@ -5948,7 +5873,6 @@
             </a:r>
           </a:p>
           <a:p>
-            <a:pPr/>
             <a:r>
               <a:t>The matching trap: a model that learns 'many tests ordered' means 'seriously ill' will fail in a unit that orders those tests routinely.</a:t>
             </a:r>
@@ -6201,7 +6125,7 @@
 </file>
 
 <file path=ppt/slides/slide2.xml><?xml version="1.0" encoding="utf-8"?>
-<p:sld xmlns:a="http://schemas.openxmlformats.org/drawingml/2006/main" xmlns:p="http://schemas.openxmlformats.org/presentationml/2006/main" xmlns:r="http://schemas.openxmlformats.org/officeDocument/2006/relationships">
+<p:sld xmlns:a="http://schemas.openxmlformats.org/drawingml/2006/main" xmlns:r="http://schemas.openxmlformats.org/officeDocument/2006/relationships" xmlns:p="http://schemas.openxmlformats.org/presentationml/2006/main">
   <p:cSld>
     <p:spTree>
       <p:nvGrpSpPr>
@@ -6209,7 +6133,14 @@
         <p:cNvGrpSpPr/>
         <p:nvPr/>
       </p:nvGrpSpPr>
-      <p:grpSpPr/>
+      <p:grpSpPr>
+        <a:xfrm>
+          <a:off x="0" y="0"/>
+          <a:ext cx="0" cy="0"/>
+          <a:chOff x="0" y="0"/>
+          <a:chExt cx="0" cy="0"/>
+        </a:xfrm>
+      </p:grpSpPr>
       <p:sp>
         <p:nvSpPr>
           <p:cNvPr id="2" name="Title 1"/>
@@ -6246,16 +6177,14 @@
           <a:bodyPr/>
           <a:lstStyle/>
           <a:p>
-            <a:pPr/>
             <a:r>
               <a:t>Last session we covered what a model is and how training works.</a:t>
             </a:r>
           </a:p>
           <a:p>
-            <a:pPr/>
-          </a:p>
-          <a:p>
-            <a:pPr/>
+            <a:endParaRPr/>
+          </a:p>
+          <a:p>
             <a:r>
               <a:t>This session is about the models themselves, and about the harder question underneath them:</a:t>
             </a:r>
@@ -6279,10 +6208,9 @@
             </a:r>
           </a:p>
           <a:p>
-            <a:pPr/>
-          </a:p>
-          <a:p>
-            <a:pPr/>
+            <a:endParaRPr/>
+          </a:p>
+          <a:p>
             <a:r>
               <a:t>That last point is where most clinical AI projects fail, and it gets most of our time today.</a:t>
             </a:r>
@@ -10316,7 +10244,7 @@
           <p:nvPr/>
         </p:nvPicPr>
         <p:blipFill>
-          <a:blip r:embed="rId3"/>
+          <a:blip r:embed="rId2"/>
           <a:stretch>
             <a:fillRect/>
           </a:stretch>
@@ -10380,7 +10308,7 @@
 </file>
 
 <file path=ppt/slides/slide28.xml><?xml version="1.0" encoding="utf-8"?>
-<p:sld xmlns:a="http://schemas.openxmlformats.org/drawingml/2006/main" xmlns:p="http://schemas.openxmlformats.org/presentationml/2006/main" xmlns:r="http://schemas.openxmlformats.org/officeDocument/2006/relationships">
+<p:sld xmlns:a="http://schemas.openxmlformats.org/drawingml/2006/main" xmlns:r="http://schemas.openxmlformats.org/officeDocument/2006/relationships" xmlns:p="http://schemas.openxmlformats.org/presentationml/2006/main">
   <p:cSld>
     <p:spTree>
       <p:nvGrpSpPr>
@@ -10388,7 +10316,14 @@
         <p:cNvGrpSpPr/>
         <p:nvPr/>
       </p:nvGrpSpPr>
-      <p:grpSpPr/>
+      <p:grpSpPr>
+        <a:xfrm>
+          <a:off x="0" y="0"/>
+          <a:ext cx="0" cy="0"/>
+          <a:chOff x="0" y="0"/>
+          <a:chExt cx="0" cy="0"/>
+        </a:xfrm>
+      </p:grpSpPr>
       <p:sp>
         <p:nvSpPr>
           <p:cNvPr id="2" name="Title 1"/>
@@ -10425,37 +10360,31 @@
           <a:bodyPr/>
           <a:lstStyle/>
           <a:p>
-            <a:pPr/>
             <a:r>
               <a:t>Discrimination asks whether the model ranks patients in the right order. That is what AUC measures.</a:t>
             </a:r>
           </a:p>
           <a:p>
-            <a:pPr/>
             <a:r>
               <a:t>Calibration asks something different: when the model says 30%, does the event happen about 30% of the time?</a:t>
             </a:r>
           </a:p>
           <a:p>
-            <a:pPr/>
             <a:r>
               <a:t>A model can rank perfectly and still be badly calibrated.</a:t>
             </a:r>
           </a:p>
           <a:p>
-            <a:pPr/>
             <a:r>
               <a:t>This matters because clinicians act on thresholds. If the numbers are wrong, the threshold is wrong.</a:t>
             </a:r>
           </a:p>
           <a:p>
-            <a:pPr/>
             <a:r>
               <a:t>Check it with a calibration plot: predicted risk against observed rate, compared with the diagonal.</a:t>
             </a:r>
           </a:p>
           <a:p>
-            <a:pPr/>
             <a:r>
               <a:t>Calibration usually degrades when a model moves to a new site, a new case mix, or a later year.</a:t>
             </a:r>
@@ -10477,7 +10406,7 @@
 </file>
 
 <file path=ppt/slides/slide29.xml><?xml version="1.0" encoding="utf-8"?>
-<p:sld xmlns:a="http://schemas.openxmlformats.org/drawingml/2006/main" xmlns:p="http://schemas.openxmlformats.org/presentationml/2006/main" xmlns:r="http://schemas.openxmlformats.org/officeDocument/2006/relationships">
+<p:sld xmlns:a="http://schemas.openxmlformats.org/drawingml/2006/main" xmlns:r="http://schemas.openxmlformats.org/officeDocument/2006/relationships" xmlns:p="http://schemas.openxmlformats.org/presentationml/2006/main">
   <p:cSld>
     <p:spTree>
       <p:nvGrpSpPr>
@@ -10485,7 +10414,14 @@
         <p:cNvGrpSpPr/>
         <p:nvPr/>
       </p:nvGrpSpPr>
-      <p:grpSpPr/>
+      <p:grpSpPr>
+        <a:xfrm>
+          <a:off x="0" y="0"/>
+          <a:ext cx="0" cy="0"/>
+          <a:chOff x="0" y="0"/>
+          <a:chExt cx="0" cy="0"/>
+        </a:xfrm>
+      </p:grpSpPr>
       <p:sp>
         <p:nvSpPr>
           <p:cNvPr id="2" name="Title 1"/>
@@ -10522,37 +10458,31 @@
           <a:bodyPr/>
           <a:lstStyle/>
           <a:p>
-            <a:pPr/>
             <a:r>
               <a:t>Internal validation: held-out data from the same source. The weakest claim, and the most commonly reported.</a:t>
             </a:r>
           </a:p>
           <a:p>
-            <a:pPr/>
             <a:r>
               <a:t>External validation: a different hospital, population or era. This is where most published models fail.</a:t>
             </a:r>
           </a:p>
           <a:p>
-            <a:pPr/>
             <a:r>
               <a:t>Prospective validation: run silently alongside usual care and compare. The first real test.</a:t>
             </a:r>
           </a:p>
           <a:p>
-            <a:pPr/>
             <a:r>
               <a:t>Impact study: does using it change outcomes? Rarely done, and the only question that ultimately matters.</a:t>
             </a:r>
           </a:p>
           <a:p>
-            <a:pPr/>
             <a:r>
               <a:t>Split by patient, never by row. The same patient on both sides inflates every number you report.</a:t>
             </a:r>
           </a:p>
           <a:p>
-            <a:pPr/>
             <a:r>
               <a:t>TRIPOD+AI (2024) sets out what a clinical prediction model should report. Use it as a checklist when reading a paper or a vendor claim.</a:t>
             </a:r>
@@ -10733,7 +10663,7 @@
           <p:nvPr/>
         </p:nvPicPr>
         <p:blipFill>
-          <a:blip r:embed="rId3"/>
+          <a:blip r:embed="rId2"/>
           <a:stretch>
             <a:fillRect/>
           </a:stretch>
@@ -10762,7 +10692,7 @@
 </file>
 
 <file path=ppt/slides/slide30.xml><?xml version="1.0" encoding="utf-8"?>
-<p:sld xmlns:a="http://schemas.openxmlformats.org/drawingml/2006/main" xmlns:p="http://schemas.openxmlformats.org/presentationml/2006/main" xmlns:r="http://schemas.openxmlformats.org/officeDocument/2006/relationships">
+<p:sld xmlns:a="http://schemas.openxmlformats.org/drawingml/2006/main" xmlns:r="http://schemas.openxmlformats.org/officeDocument/2006/relationships" xmlns:p="http://schemas.openxmlformats.org/presentationml/2006/main">
   <p:cSld>
     <p:spTree>
       <p:nvGrpSpPr>
@@ -10770,7 +10700,14 @@
         <p:cNvGrpSpPr/>
         <p:nvPr/>
       </p:nvGrpSpPr>
-      <p:grpSpPr/>
+      <p:grpSpPr>
+        <a:xfrm>
+          <a:off x="0" y="0"/>
+          <a:ext cx="0" cy="0"/>
+          <a:chOff x="0" y="0"/>
+          <a:chExt cx="0" cy="0"/>
+        </a:xfrm>
+      </p:grpSpPr>
       <p:sp>
         <p:nvSpPr>
           <p:cNvPr id="2" name="Title 1"/>
@@ -10807,13 +10744,11 @@
           <a:bodyPr/>
           <a:lstStyle/>
           <a:p>
-            <a:pPr/>
             <a:r>
               <a:t>A model trained on historical care learns historical inequity alongside clinical signal.</a:t>
             </a:r>
           </a:p>
           <a:p>
-            <a:pPr/>
             <a:r>
               <a:t>Obermeyer and colleagues (Science, 2019) examined a widely used US population-health algorithm:</a:t>
             </a:r>
@@ -10837,25 +10772,21 @@
             </a:r>
           </a:p>
           <a:p>
-            <a:pPr/>
             <a:r>
               <a:t>The algorithm was never given race. The proxy carried it.</a:t>
             </a:r>
           </a:p>
           <a:p>
-            <a:pPr/>
             <a:r>
               <a:t>Changing the target to a direct measure of illness substantially increased the proportion of Black patients identified for extra care.</a:t>
             </a:r>
           </a:p>
           <a:p>
-            <a:pPr/>
             <a:r>
               <a:t>Report performance separately by age, sex, ethnicity, language and deprivation, before deployment and after.</a:t>
             </a:r>
           </a:p>
           <a:p>
-            <a:pPr/>
             <a:r>
               <a:t>Ask what the label actually measures. Cost, referral and coded diagnosis are decisions, not conditions.</a:t>
             </a:r>
@@ -10871,7 +10802,7 @@
 </file>
 
 <file path=ppt/slides/slide31.xml><?xml version="1.0" encoding="utf-8"?>
-<p:sld xmlns:a="http://schemas.openxmlformats.org/drawingml/2006/main" xmlns:p="http://schemas.openxmlformats.org/presentationml/2006/main" xmlns:r="http://schemas.openxmlformats.org/officeDocument/2006/relationships">
+<p:sld xmlns:a="http://schemas.openxmlformats.org/drawingml/2006/main" xmlns:r="http://schemas.openxmlformats.org/officeDocument/2006/relationships" xmlns:p="http://schemas.openxmlformats.org/presentationml/2006/main">
   <p:cSld>
     <p:spTree>
       <p:nvGrpSpPr>
@@ -10879,7 +10810,14 @@
         <p:cNvGrpSpPr/>
         <p:nvPr/>
       </p:nvGrpSpPr>
-      <p:grpSpPr/>
+      <p:grpSpPr>
+        <a:xfrm>
+          <a:off x="0" y="0"/>
+          <a:ext cx="0" cy="0"/>
+          <a:chOff x="0" y="0"/>
+          <a:chExt cx="0" cy="0"/>
+        </a:xfrm>
+      </p:grpSpPr>
       <p:sp>
         <p:nvSpPr>
           <p:cNvPr id="2" name="Title 1"/>
@@ -10896,7 +10834,7 @@
           <a:lstStyle/>
           <a:p>
             <a:r>
-              <a:t>A Cautionary Case</a:t>
+              <a:t>Session 2 — What to Take Away</a:t>
             </a:r>
           </a:p>
         </p:txBody>
@@ -10916,42 +10854,41 @@
           <a:bodyPr/>
           <a:lstStyle/>
           <a:p>
-            <a:pPr/>
-            <a:r>
-              <a:t>A widely deployed proprietary sepsis prediction model was independently validated at an academic health system (Wong et al., JAMA Internal Medicine, 2021).</a:t>
-            </a:r>
-          </a:p>
-          <a:p>
-            <a:pPr/>
-            <a:r>
-              <a:t>Measured discrimination was substantially below the figures the vendor had reported.</a:t>
-            </a:r>
-          </a:p>
-          <a:p>
-            <a:pPr/>
-            <a:r>
-              <a:t>It missed a large share of sepsis cases, while generating alerts on a substantial fraction of all admissions.</a:t>
-            </a:r>
-          </a:p>
-          <a:p>
-            <a:pPr/>
-            <a:r>
-              <a:t>Two failures compounding: the model underperformed, and the alert burden made the output hard to act on.</a:t>
-            </a:r>
-          </a:p>
-          <a:p>
-            <a:pPr/>
-            <a:r>
-              <a:t>It had been in wide clinical use before this independent evaluation was published.</a:t>
-            </a:r>
-          </a:p>
-          <a:p>
-            <a:pPr/>
-          </a:p>
-          <a:p>
-            <a:pPr/>
-            <a:r>
-              <a:t>The lesson is not that the technique is flawed. It is that a vendor's performance figures are not evidence of performance in your hospital.</a:t>
+            <a:r>
+              <a:t>Tree ensembles remain the workhorse for tabular clinical data. Start there.</a:t>
+            </a:r>
+          </a:p>
+          <a:p>
+            <a:r>
+              <a:t>Interpretability and accuracy trade off. Choose deliberately, and bring SHAP if you give up readability.</a:t>
+            </a:r>
+          </a:p>
+          <a:p>
+            <a:r>
+              <a:t>Accuracy misleads whenever the outcome is rare. Use precision, recall and calibration together.</a:t>
+            </a:r>
+          </a:p>
+          <a:p>
+            <a:r>
+              <a:t>The validation that counts is the one done somewhere else, prospectively.</a:t>
+            </a:r>
+          </a:p>
+          <a:p>
+            <a:r>
+              <a:t>Check who the model fails, not only how often it fails.</a:t>
+            </a:r>
+          </a:p>
+          <a:p>
+            <a:r>
+              <a:t>Most of the work is in the data, and most of the risk is in the label.</a:t>
+            </a:r>
+          </a:p>
+          <a:p>
+            <a:endParaRPr/>
+          </a:p>
+          <a:p>
+            <a:r>
+              <a:t>Next session: deep learning, large language models, and what deployment actually demands.</a:t>
             </a:r>
           </a:p>
         </p:txBody>
@@ -10965,106 +10902,6 @@
 </file>
 
 <file path=ppt/slides/slide32.xml><?xml version="1.0" encoding="utf-8"?>
-<p:sld xmlns:a="http://schemas.openxmlformats.org/drawingml/2006/main" xmlns:p="http://schemas.openxmlformats.org/presentationml/2006/main" xmlns:r="http://schemas.openxmlformats.org/officeDocument/2006/relationships">
-  <p:cSld>
-    <p:spTree>
-      <p:nvGrpSpPr>
-        <p:cNvPr id="1" name=""/>
-        <p:cNvGrpSpPr/>
-        <p:nvPr/>
-      </p:nvGrpSpPr>
-      <p:grpSpPr/>
-      <p:sp>
-        <p:nvSpPr>
-          <p:cNvPr id="2" name="Title 1"/>
-          <p:cNvSpPr>
-            <a:spLocks noGrp="1"/>
-          </p:cNvSpPr>
-          <p:nvPr>
-            <p:ph type="title"/>
-          </p:nvPr>
-        </p:nvSpPr>
-        <p:spPr/>
-        <p:txBody>
-          <a:bodyPr/>
-          <a:lstStyle/>
-          <a:p>
-            <a:r>
-              <a:t>Session 2 — What to Take Away</a:t>
-            </a:r>
-          </a:p>
-        </p:txBody>
-      </p:sp>
-      <p:sp>
-        <p:nvSpPr>
-          <p:cNvPr id="3" name="Content Placeholder 2"/>
-          <p:cNvSpPr>
-            <a:spLocks noGrp="1"/>
-          </p:cNvSpPr>
-          <p:nvPr>
-            <p:ph idx="1"/>
-          </p:nvPr>
-        </p:nvSpPr>
-        <p:spPr/>
-        <p:txBody>
-          <a:bodyPr/>
-          <a:lstStyle/>
-          <a:p>
-            <a:pPr/>
-            <a:r>
-              <a:t>Tree ensembles remain the workhorse for tabular clinical data. Start there.</a:t>
-            </a:r>
-          </a:p>
-          <a:p>
-            <a:pPr/>
-            <a:r>
-              <a:t>Interpretability and accuracy trade off. Choose deliberately, and bring SHAP if you give up readability.</a:t>
-            </a:r>
-          </a:p>
-          <a:p>
-            <a:pPr/>
-            <a:r>
-              <a:t>Accuracy misleads whenever the outcome is rare. Use precision, recall and calibration together.</a:t>
-            </a:r>
-          </a:p>
-          <a:p>
-            <a:pPr/>
-            <a:r>
-              <a:t>The validation that counts is the one done somewhere else, prospectively.</a:t>
-            </a:r>
-          </a:p>
-          <a:p>
-            <a:pPr/>
-            <a:r>
-              <a:t>Check who the model fails, not only how often it fails.</a:t>
-            </a:r>
-          </a:p>
-          <a:p>
-            <a:pPr/>
-            <a:r>
-              <a:t>Most of the work is in the data, and most of the risk is in the label.</a:t>
-            </a:r>
-          </a:p>
-          <a:p>
-            <a:pPr/>
-          </a:p>
-          <a:p>
-            <a:pPr/>
-            <a:r>
-              <a:t>Next session: deep learning, large language models, and what deployment actually demands.</a:t>
-            </a:r>
-          </a:p>
-        </p:txBody>
-      </p:sp>
-    </p:spTree>
-  </p:cSld>
-  <p:clrMapOvr>
-    <a:masterClrMapping/>
-  </p:clrMapOvr>
-</p:sld>
-</file>
-
-<file path=ppt/slides/slide33.xml><?xml version="1.0" encoding="utf-8"?>
 <p:sld xmlns:a="http://schemas.openxmlformats.org/drawingml/2006/main" xmlns:r="http://schemas.openxmlformats.org/officeDocument/2006/relationships" xmlns:p="http://schemas.openxmlformats.org/presentationml/2006/main">
   <p:cSld>
     <p:spTree>
@@ -11115,36 +10952,6 @@
           </a:p>
         </p:txBody>
       </p:sp>
-      <p:pic>
-        <p:nvPicPr>
-          <p:cNvPr id="3" name="Picture 2">
-            <a:extLst>
-              <a:ext uri="{FF2B5EF4-FFF2-40B4-BE49-F238E27FC236}">
-                <a16:creationId xmlns:a16="http://schemas.microsoft.com/office/drawing/2014/main" id="{5BE779F4-E0F1-5BC6-2417-93E6D6C2C83C}"/>
-              </a:ext>
-            </a:extLst>
-          </p:cNvPr>
-          <p:cNvPicPr>
-            <a:picLocks noChangeAspect="1"/>
-          </p:cNvPicPr>
-          <p:nvPr/>
-        </p:nvPicPr>
-        <p:blipFill>
-          <a:blip r:embed="rId2"/>
-          <a:stretch>
-            <a:fillRect/>
-          </a:stretch>
-        </p:blipFill>
-        <p:spPr>
-          <a:xfrm>
-            <a:off x="5153919" y="759103"/>
-            <a:ext cx="5117422" cy="5330650"/>
-          </a:xfrm>
-          <a:prstGeom prst="rect">
-            <a:avLst/>
-          </a:prstGeom>
-        </p:spPr>
-      </p:pic>
     </p:spTree>
     <p:extLst>
       <p:ext uri="{BB962C8B-B14F-4D97-AF65-F5344CB8AC3E}">
@@ -11397,36 +11204,6 @@
               </a:rPr>
               <a:t>Target: Low Risk, High Risk</a:t>
             </a:r>
-            <a:r>
-              <a:rPr lang="en-US" sz="1400" kern="0" spc="-30" dirty="0">
-                <a:solidFill>
-                  <a:srgbClr val="48B491"/>
-                </a:solidFill>
-                <a:latin typeface="Poppins" pitchFamily="2" charset="77"/>
-                <a:cs typeface="Poppins" pitchFamily="2" charset="77"/>
-              </a:rPr>
-              <a:t/>
-            </a:r>
-            <a:r>
-              <a:rPr lang="en-US" sz="1400" kern="0" spc="-30" dirty="0">
-                <a:solidFill>
-                  <a:schemeClr val="accent3"/>
-                </a:solidFill>
-                <a:latin typeface="Poppins" pitchFamily="2" charset="77"/>
-                <a:cs typeface="Poppins" pitchFamily="2" charset="77"/>
-              </a:rPr>
-              <a:t/>
-            </a:r>
-            <a:r>
-              <a:rPr lang="en-US" sz="1400" kern="0" spc="-30" dirty="0">
-                <a:solidFill>
-                  <a:srgbClr val="FF0000"/>
-                </a:solidFill>
-                <a:latin typeface="Poppins" pitchFamily="2" charset="77"/>
-                <a:cs typeface="Poppins" pitchFamily="2" charset="77"/>
-              </a:rPr>
-              <a:t/>
-            </a:r>
           </a:p>
           <a:p>
             <a:r>
@@ -11438,16 +11215,6 @@
                 <a:cs typeface="Poppins" pitchFamily="2" charset="77"/>
               </a:rPr>
               <a:t>Features: Lactate, Heart Rate, Resp Rate</a:t>
-            </a:r>
-            <a:r>
-              <a:rPr lang="en-US" sz="1400" kern="0" spc="-30" dirty="0">
-                <a:solidFill>
-                  <a:srgbClr val="009EE2"/>
-                </a:solidFill>
-                <a:latin typeface="Poppins" pitchFamily="2" charset="77"/>
-                <a:cs typeface="Poppins" pitchFamily="2" charset="77"/>
-              </a:rPr>
-              <a:t/>
             </a:r>
           </a:p>
           <a:p>
@@ -12238,16 +12005,6 @@
               </a:rPr>
               <a:t>Target: Length of Stay</a:t>
             </a:r>
-            <a:r>
-              <a:rPr lang="en-US" sz="1400" kern="0" spc="-30" dirty="0">
-                <a:solidFill>
-                  <a:srgbClr val="48B491"/>
-                </a:solidFill>
-                <a:latin typeface="Poppins" pitchFamily="2" charset="77"/>
-                <a:cs typeface="Poppins" pitchFamily="2" charset="77"/>
-              </a:rPr>
-              <a:t/>
-            </a:r>
           </a:p>
           <a:p>
             <a:r>
@@ -12259,16 +12016,6 @@
                 <a:cs typeface="Poppins" pitchFamily="2" charset="77"/>
               </a:rPr>
               <a:t>Features: Age, Severity, Frailty</a:t>
-            </a:r>
-            <a:r>
-              <a:rPr lang="en-US" sz="1400" kern="0" spc="-30" dirty="0">
-                <a:solidFill>
-                  <a:srgbClr val="00B0F0"/>
-                </a:solidFill>
-                <a:latin typeface="Poppins" pitchFamily="2" charset="77"/>
-                <a:cs typeface="Poppins" pitchFamily="2" charset="77"/>
-              </a:rPr>
-              <a:t/>
             </a:r>
           </a:p>
           <a:p>
@@ -12321,26 +12068,6 @@
               </a:rPr>
               <a:t>4.9 days, n=35</a:t>
             </a:r>
-            <a:r>
-              <a:rPr lang="en-US" sz="1200" kern="0" spc="-30" dirty="0" err="1">
-                <a:solidFill>
-                  <a:srgbClr val="48B491"/>
-                </a:solidFill>
-                <a:latin typeface="Poppins" pitchFamily="2" charset="77"/>
-                <a:cs typeface="Poppins" pitchFamily="2" charset="77"/>
-              </a:rPr>
-              <a:t/>
-            </a:r>
-            <a:r>
-              <a:rPr lang="en-US" sz="1200" kern="0" spc="-30" dirty="0">
-                <a:solidFill>
-                  <a:srgbClr val="48B491"/>
-                </a:solidFill>
-                <a:latin typeface="Poppins" pitchFamily="2" charset="77"/>
-                <a:cs typeface="Poppins" pitchFamily="2" charset="77"/>
-              </a:rPr>
-              <a:t/>
-            </a:r>
           </a:p>
           <a:p>
             <a:pPr algn="ctr"/>
@@ -12396,26 +12123,6 @@
               </a:rPr>
               <a:t>6.8 days, n=65</a:t>
             </a:r>
-            <a:r>
-              <a:rPr lang="en-US" sz="1200" kern="0" spc="-30" dirty="0" err="1">
-                <a:solidFill>
-                  <a:srgbClr val="48B491"/>
-                </a:solidFill>
-                <a:latin typeface="Poppins" pitchFamily="2" charset="77"/>
-                <a:cs typeface="Poppins" pitchFamily="2" charset="77"/>
-              </a:rPr>
-              <a:t/>
-            </a:r>
-            <a:r>
-              <a:rPr lang="en-US" sz="1200" kern="0" spc="-30" dirty="0">
-                <a:solidFill>
-                  <a:srgbClr val="48B491"/>
-                </a:solidFill>
-                <a:latin typeface="Poppins" pitchFamily="2" charset="77"/>
-                <a:cs typeface="Poppins" pitchFamily="2" charset="77"/>
-              </a:rPr>
-              <a:t/>
-            </a:r>
           </a:p>
           <a:p>
             <a:pPr algn="ctr"/>
@@ -12471,26 +12178,6 @@
               </a:rPr>
               <a:t>4.2 days, n=22</a:t>
             </a:r>
-            <a:r>
-              <a:rPr lang="en-US" sz="1200" kern="0" spc="-30" dirty="0" err="1">
-                <a:solidFill>
-                  <a:srgbClr val="48B491"/>
-                </a:solidFill>
-                <a:latin typeface="Poppins" pitchFamily="2" charset="77"/>
-                <a:cs typeface="Poppins" pitchFamily="2" charset="77"/>
-              </a:rPr>
-              <a:t/>
-            </a:r>
-            <a:r>
-              <a:rPr lang="en-US" sz="1200" kern="0" spc="-30" dirty="0">
-                <a:solidFill>
-                  <a:srgbClr val="48B491"/>
-                </a:solidFill>
-                <a:latin typeface="Poppins" pitchFamily="2" charset="77"/>
-                <a:cs typeface="Poppins" pitchFamily="2" charset="77"/>
-              </a:rPr>
-              <a:t/>
-            </a:r>
           </a:p>
         </p:txBody>
       </p:sp>
@@ -12533,26 +12220,6 @@
               </a:rPr>
               <a:t>5.6 days, n=13</a:t>
             </a:r>
-            <a:r>
-              <a:rPr lang="en-US" sz="1200" kern="0" spc="-30" dirty="0" err="1">
-                <a:solidFill>
-                  <a:srgbClr val="48B491"/>
-                </a:solidFill>
-                <a:latin typeface="Poppins" pitchFamily="2" charset="77"/>
-                <a:cs typeface="Poppins" pitchFamily="2" charset="77"/>
-              </a:rPr>
-              <a:t/>
-            </a:r>
-            <a:r>
-              <a:rPr lang="en-US" sz="1200" kern="0" spc="-30" dirty="0">
-                <a:solidFill>
-                  <a:srgbClr val="48B491"/>
-                </a:solidFill>
-                <a:latin typeface="Poppins" pitchFamily="2" charset="77"/>
-                <a:cs typeface="Poppins" pitchFamily="2" charset="77"/>
-              </a:rPr>
-              <a:t/>
-            </a:r>
           </a:p>
         </p:txBody>
       </p:sp>
@@ -12595,26 +12262,6 @@
               </a:rPr>
               <a:t>7.5 days, n=27</a:t>
             </a:r>
-            <a:r>
-              <a:rPr lang="en-US" sz="1200" kern="0" spc="-30" dirty="0" err="1">
-                <a:solidFill>
-                  <a:srgbClr val="48B491"/>
-                </a:solidFill>
-                <a:latin typeface="Poppins" pitchFamily="2" charset="77"/>
-                <a:cs typeface="Poppins" pitchFamily="2" charset="77"/>
-              </a:rPr>
-              <a:t/>
-            </a:r>
-            <a:r>
-              <a:rPr lang="en-US" sz="1200" kern="0" spc="-30" dirty="0">
-                <a:solidFill>
-                  <a:srgbClr val="48B491"/>
-                </a:solidFill>
-                <a:latin typeface="Poppins" pitchFamily="2" charset="77"/>
-                <a:cs typeface="Poppins" pitchFamily="2" charset="77"/>
-              </a:rPr>
-              <a:t/>
-            </a:r>
           </a:p>
         </p:txBody>
       </p:sp>
@@ -12657,26 +12304,6 @@
               </a:rPr>
               <a:t>6.1 days, n=100</a:t>
             </a:r>
-            <a:r>
-              <a:rPr lang="en-US" sz="1200" kern="0" spc="-30" dirty="0" err="1">
-                <a:solidFill>
-                  <a:srgbClr val="48B491"/>
-                </a:solidFill>
-                <a:latin typeface="Poppins" pitchFamily="2" charset="77"/>
-                <a:cs typeface="Poppins" pitchFamily="2" charset="77"/>
-              </a:rPr>
-              <a:t/>
-            </a:r>
-            <a:r>
-              <a:rPr lang="en-US" sz="1200" kern="0" spc="-30" dirty="0">
-                <a:solidFill>
-                  <a:srgbClr val="48B491"/>
-                </a:solidFill>
-                <a:latin typeface="Poppins" pitchFamily="2" charset="77"/>
-                <a:cs typeface="Poppins" pitchFamily="2" charset="77"/>
-              </a:rPr>
-              <a:t/>
-            </a:r>
           </a:p>
           <a:p>
             <a:pPr algn="ctr"/>
@@ -12731,26 +12358,6 @@
                 <a:cs typeface="Poppins" pitchFamily="2" charset="77"/>
               </a:rPr>
               <a:t>6.2 days, n=38</a:t>
-            </a:r>
-            <a:r>
-              <a:rPr lang="en-US" sz="1200" kern="0" spc="-30" dirty="0" err="1">
-                <a:solidFill>
-                  <a:srgbClr val="48B491"/>
-                </a:solidFill>
-                <a:latin typeface="Poppins" pitchFamily="2" charset="77"/>
-                <a:cs typeface="Poppins" pitchFamily="2" charset="77"/>
-              </a:rPr>
-              <a:t/>
-            </a:r>
-            <a:r>
-              <a:rPr lang="en-US" sz="1200" kern="0" spc="-30" dirty="0">
-                <a:solidFill>
-                  <a:srgbClr val="48B491"/>
-                </a:solidFill>
-                <a:latin typeface="Poppins" pitchFamily="2" charset="77"/>
-                <a:cs typeface="Poppins" pitchFamily="2" charset="77"/>
-              </a:rPr>
-              <a:t/>
             </a:r>
           </a:p>
         </p:txBody>

</xml_diff>